<commit_message>
Update weeks 4-5 course materials
Revise the Week 4 notes into a combined Weeks 4-5 page, including updated lecture scope, new sampling-design examples, and expanded source links for the polling and UK Biobank material. Regenerate the rendered site output and refresh the related lecture slides, schedule, review, study guide, syllabus, and other published PDFs.
</commit_message>
<xml_diff>
--- a/docs/lecture_slides/Week 4/Week4_Lecture8_Slides_9_14_2026.pptx
+++ b/docs/lecture_slides/Week 4/Week4_Lecture8_Slides_9_14_2026.pptx
@@ -25,8 +25,6 @@
     <p:sldId id="273" r:id="rId19"/>
     <p:sldId id="274" r:id="rId20"/>
     <p:sldId id="275" r:id="rId21"/>
-    <p:sldId id="276" r:id="rId22"/>
-    <p:sldId id="277" r:id="rId23"/>
   </p:sldIdLst>
   <p:sldSz cx="12192000" cy="6858000"/>
   <p:notesSz cx="6858000" cy="9144000"/>
@@ -280,7 +278,7 @@
           <a:p>
             <a:fld id="{06882561-BD16-4A95-ACA1-5204E478F2FE}" type="datetimeFigureOut">
               <a:rPr lang="en-US" smtClean="0"/>
-              <a:t>9/15/2026</a:t>
+              <a:t>9/21/2026</a:t>
             </a:fld>
             <a:endParaRPr lang="en-US"/>
           </a:p>
@@ -478,7 +476,7 @@
           <a:p>
             <a:fld id="{06882561-BD16-4A95-ACA1-5204E478F2FE}" type="datetimeFigureOut">
               <a:rPr lang="en-US" smtClean="0"/>
-              <a:t>9/15/2026</a:t>
+              <a:t>9/21/2026</a:t>
             </a:fld>
             <a:endParaRPr lang="en-US"/>
           </a:p>
@@ -686,7 +684,7 @@
           <a:p>
             <a:fld id="{06882561-BD16-4A95-ACA1-5204E478F2FE}" type="datetimeFigureOut">
               <a:rPr lang="en-US" smtClean="0"/>
-              <a:t>9/15/2026</a:t>
+              <a:t>9/21/2026</a:t>
             </a:fld>
             <a:endParaRPr lang="en-US"/>
           </a:p>
@@ -884,7 +882,7 @@
           <a:p>
             <a:fld id="{06882561-BD16-4A95-ACA1-5204E478F2FE}" type="datetimeFigureOut">
               <a:rPr lang="en-US" smtClean="0"/>
-              <a:t>9/15/2026</a:t>
+              <a:t>9/21/2026</a:t>
             </a:fld>
             <a:endParaRPr lang="en-US"/>
           </a:p>
@@ -1159,7 +1157,7 @@
           <a:p>
             <a:fld id="{06882561-BD16-4A95-ACA1-5204E478F2FE}" type="datetimeFigureOut">
               <a:rPr lang="en-US" smtClean="0"/>
-              <a:t>9/15/2026</a:t>
+              <a:t>9/21/2026</a:t>
             </a:fld>
             <a:endParaRPr lang="en-US"/>
           </a:p>
@@ -1424,7 +1422,7 @@
           <a:p>
             <a:fld id="{06882561-BD16-4A95-ACA1-5204E478F2FE}" type="datetimeFigureOut">
               <a:rPr lang="en-US" smtClean="0"/>
-              <a:t>9/15/2026</a:t>
+              <a:t>9/21/2026</a:t>
             </a:fld>
             <a:endParaRPr lang="en-US"/>
           </a:p>
@@ -1836,7 +1834,7 @@
           <a:p>
             <a:fld id="{06882561-BD16-4A95-ACA1-5204E478F2FE}" type="datetimeFigureOut">
               <a:rPr lang="en-US" smtClean="0"/>
-              <a:t>9/15/2026</a:t>
+              <a:t>9/21/2026</a:t>
             </a:fld>
             <a:endParaRPr lang="en-US"/>
           </a:p>
@@ -1977,7 +1975,7 @@
           <a:p>
             <a:fld id="{06882561-BD16-4A95-ACA1-5204E478F2FE}" type="datetimeFigureOut">
               <a:rPr lang="en-US" smtClean="0"/>
-              <a:t>9/15/2026</a:t>
+              <a:t>9/21/2026</a:t>
             </a:fld>
             <a:endParaRPr lang="en-US"/>
           </a:p>
@@ -2090,7 +2088,7 @@
           <a:p>
             <a:fld id="{06882561-BD16-4A95-ACA1-5204E478F2FE}" type="datetimeFigureOut">
               <a:rPr lang="en-US" smtClean="0"/>
-              <a:t>9/15/2026</a:t>
+              <a:t>9/21/2026</a:t>
             </a:fld>
             <a:endParaRPr lang="en-US"/>
           </a:p>
@@ -2401,7 +2399,7 @@
           <a:p>
             <a:fld id="{06882561-BD16-4A95-ACA1-5204E478F2FE}" type="datetimeFigureOut">
               <a:rPr lang="en-US" smtClean="0"/>
-              <a:t>9/15/2026</a:t>
+              <a:t>9/21/2026</a:t>
             </a:fld>
             <a:endParaRPr lang="en-US"/>
           </a:p>
@@ -2689,7 +2687,7 @@
           <a:p>
             <a:fld id="{06882561-BD16-4A95-ACA1-5204E478F2FE}" type="datetimeFigureOut">
               <a:rPr lang="en-US" smtClean="0"/>
-              <a:t>9/15/2026</a:t>
+              <a:t>9/21/2026</a:t>
             </a:fld>
             <a:endParaRPr lang="en-US"/>
           </a:p>
@@ -2930,7 +2928,7 @@
           <a:p>
             <a:fld id="{06882561-BD16-4A95-ACA1-5204E478F2FE}" type="datetimeFigureOut">
               <a:rPr lang="en-US" smtClean="0"/>
-              <a:t>9/15/2026</a:t>
+              <a:t>9/21/2026</a:t>
             </a:fld>
             <a:endParaRPr lang="en-US"/>
           </a:p>
@@ -11647,1628 +11645,6 @@
     </p:tnLst>
     <p:bldLst>
       <p:bldP spid="7" grpId="0"/>
-    </p:bldLst>
-  </p:timing>
-</p:sld>
-</file>
-
-<file path=ppt/slides/slide21.xml><?xml version="1.0" encoding="utf-8"?>
-<p:sld xmlns:a="http://schemas.openxmlformats.org/drawingml/2006/main" xmlns:r="http://schemas.openxmlformats.org/officeDocument/2006/relationships" xmlns:p="http://schemas.openxmlformats.org/presentationml/2006/main">
-  <p:cSld>
-    <p:spTree>
-      <p:nvGrpSpPr>
-        <p:cNvPr id="1" name=""/>
-        <p:cNvGrpSpPr/>
-        <p:nvPr/>
-      </p:nvGrpSpPr>
-      <p:grpSpPr>
-        <a:xfrm>
-          <a:off x="0" y="0"/>
-          <a:ext cx="0" cy="0"/>
-          <a:chOff x="0" y="0"/>
-          <a:chExt cx="0" cy="0"/>
-        </a:xfrm>
-      </p:grpSpPr>
-      <p:sp>
-        <p:nvSpPr>
-          <p:cNvPr id="2" name="Title 1">
-            <a:extLst>
-              <a:ext uri="{FF2B5EF4-FFF2-40B4-BE49-F238E27FC236}">
-                <a16:creationId xmlns:a16="http://schemas.microsoft.com/office/drawing/2014/main" id="{CB8097E2-4E3E-168E-D9EF-BE86DD21F95F}"/>
-              </a:ext>
-            </a:extLst>
-          </p:cNvPr>
-          <p:cNvSpPr>
-            <a:spLocks noGrp="1"/>
-          </p:cNvSpPr>
-          <p:nvPr>
-            <p:ph type="title"/>
-          </p:nvPr>
-        </p:nvSpPr>
-        <p:spPr/>
-        <p:txBody>
-          <a:bodyPr>
-            <a:noAutofit/>
-          </a:bodyPr>
-          <a:lstStyle/>
-          <a:p>
-            <a:r>
-              <a:rPr lang="en-US">
-                <a:solidFill>
-                  <a:srgbClr val="1F3864"/>
-                </a:solidFill>
-              </a:rPr>
-              <a:t>Systematic sample</a:t>
-            </a:r>
-          </a:p>
-        </p:txBody>
-      </p:sp>
-      <p:sp>
-        <p:nvSpPr>
-          <p:cNvPr id="4" name="Slide Number Placeholder 3">
-            <a:extLst>
-              <a:ext uri="{FF2B5EF4-FFF2-40B4-BE49-F238E27FC236}">
-                <a16:creationId xmlns:a16="http://schemas.microsoft.com/office/drawing/2014/main" id="{8CC44AB4-3472-45D6-45C0-B84299A6D6F4}"/>
-              </a:ext>
-            </a:extLst>
-          </p:cNvPr>
-          <p:cNvSpPr>
-            <a:spLocks noGrp="1"/>
-          </p:cNvSpPr>
-          <p:nvPr>
-            <p:ph type="sldNum" sz="quarter" idx="12"/>
-          </p:nvPr>
-        </p:nvSpPr>
-        <p:spPr/>
-        <p:txBody>
-          <a:bodyPr/>
-          <a:lstStyle/>
-          <a:p>
-            <a:fld id="{A80A81DD-F10A-4B1C-963A-0ABBB4865886}" type="slidenum">
-              <a:rPr lang="en-US" sz="1600" smtClean="0"/>
-              <a:t>21</a:t>
-            </a:fld>
-            <a:endParaRPr lang="en-US" sz="1600"/>
-          </a:p>
-        </p:txBody>
-      </p:sp>
-      <p:sp>
-        <p:nvSpPr>
-          <p:cNvPr id="5" name="TextBox 4">
-            <a:extLst>
-              <a:ext uri="{FF2B5EF4-FFF2-40B4-BE49-F238E27FC236}">
-                <a16:creationId xmlns:a16="http://schemas.microsoft.com/office/drawing/2014/main" id="{35CDA281-DC4B-F536-974A-7668B2AF62C6}"/>
-              </a:ext>
-            </a:extLst>
-          </p:cNvPr>
-          <p:cNvSpPr txBox="1"/>
-          <p:nvPr/>
-        </p:nvSpPr>
-        <p:spPr>
-          <a:xfrm>
-            <a:off x="762000" y="1841500"/>
-            <a:ext cx="2921000" cy="345440"/>
-          </a:xfrm>
-          <a:prstGeom prst="rect">
-            <a:avLst/>
-          </a:prstGeom>
-          <a:noFill/>
-        </p:spPr>
-        <p:txBody>
-          <a:bodyPr vert="horz" wrap="square" rtlCol="0">
-            <a:noAutofit/>
-          </a:bodyPr>
-          <a:lstStyle/>
-          <a:p>
-            <a:r>
-              <a:rPr lang="en-US" sz="1600" b="1">
-                <a:solidFill>
-                  <a:srgbClr val="C00000"/>
-                </a:solidFill>
-              </a:rPr>
-              <a:t>systematic sample</a:t>
-            </a:r>
-          </a:p>
-        </p:txBody>
-      </p:sp>
-      <p:sp>
-        <p:nvSpPr>
-          <p:cNvPr id="6" name="TextBox 5">
-            <a:extLst>
-              <a:ext uri="{FF2B5EF4-FFF2-40B4-BE49-F238E27FC236}">
-                <a16:creationId xmlns:a16="http://schemas.microsoft.com/office/drawing/2014/main" id="{7D01DC53-F5E2-B64C-85E7-BE250E06A5B0}"/>
-              </a:ext>
-            </a:extLst>
-          </p:cNvPr>
-          <p:cNvSpPr txBox="1"/>
-          <p:nvPr/>
-        </p:nvSpPr>
-        <p:spPr>
-          <a:xfrm>
-            <a:off x="3784600" y="1841499"/>
-            <a:ext cx="7645400" cy="589280"/>
-          </a:xfrm>
-          <a:prstGeom prst="rect">
-            <a:avLst/>
-          </a:prstGeom>
-          <a:noFill/>
-        </p:spPr>
-        <p:txBody>
-          <a:bodyPr vert="horz" wrap="square" rtlCol="0">
-            <a:noAutofit/>
-          </a:bodyPr>
-          <a:lstStyle/>
-          <a:p>
-            <a:r>
-              <a:rPr lang="en-US" sz="1600">
-                <a:solidFill>
-                  <a:srgbClr val="000000"/>
-                </a:solidFill>
-              </a:rPr>
-              <a:t>pick a random starting point among the first k units of an ordered list, then take every kth unit after it</a:t>
-            </a:r>
-          </a:p>
-        </p:txBody>
-      </p:sp>
-      <p:sp>
-        <p:nvSpPr>
-          <p:cNvPr id="7" name="TextBox 6">
-            <a:extLst>
-              <a:ext uri="{FF2B5EF4-FFF2-40B4-BE49-F238E27FC236}">
-                <a16:creationId xmlns:a16="http://schemas.microsoft.com/office/drawing/2014/main" id="{EAF71F7A-F91D-D57F-1674-50E9AF83A26F}"/>
-              </a:ext>
-            </a:extLst>
-          </p:cNvPr>
-          <p:cNvSpPr txBox="1"/>
-          <p:nvPr/>
-        </p:nvSpPr>
-        <p:spPr>
-          <a:xfrm>
-            <a:off x="762000" y="2532380"/>
-            <a:ext cx="10668000" cy="345440"/>
-          </a:xfrm>
-          <a:prstGeom prst="rect">
-            <a:avLst/>
-          </a:prstGeom>
-          <a:noFill/>
-        </p:spPr>
-        <p:txBody>
-          <a:bodyPr vert="horz" wrap="square" rtlCol="0">
-            <a:noAutofit/>
-          </a:bodyPr>
-          <a:lstStyle/>
-          <a:p>
-            <a:r>
-              <a:rPr lang="en-US" sz="1600" b="1">
-                <a:solidFill>
-                  <a:srgbClr val="1F3864"/>
-                </a:solidFill>
-              </a:rPr>
-              <a:t>k = N/n = 100/20 = 5.  Random start = 2, so we take list positions 2, 7, 12, 17, ... , 97</a:t>
-            </a:r>
-          </a:p>
-        </p:txBody>
-      </p:sp>
-      <p:pic>
-        <p:nvPicPr>
-          <p:cNvPr id="9" name="l8_design_systematic.png">
-            <a:extLst>
-              <a:ext uri="{FF2B5EF4-FFF2-40B4-BE49-F238E27FC236}">
-                <a16:creationId xmlns:a16="http://schemas.microsoft.com/office/drawing/2014/main" id="{85D54DE1-2786-33F5-0EF9-7F4D43CDC65B}"/>
-              </a:ext>
-            </a:extLst>
-          </p:cNvPr>
-          <p:cNvPicPr>
-            <a:picLocks/>
-          </p:cNvPicPr>
-          <p:nvPr/>
-        </p:nvPicPr>
-        <p:blipFill>
-          <a:blip r:embed="rId2">
-            <a:extLst>
-              <a:ext uri="{28A0092B-C50C-407E-A947-70E740481C1C}">
-                <a14:useLocalDpi xmlns:a14="http://schemas.microsoft.com/office/drawing/2010/main" val="0"/>
-              </a:ext>
-            </a:extLst>
-          </a:blip>
-          <a:stretch>
-            <a:fillRect/>
-          </a:stretch>
-        </p:blipFill>
-        <p:spPr>
-          <a:xfrm>
-            <a:off x="762000" y="2928620"/>
-            <a:ext cx="10668000" cy="2921000"/>
-          </a:xfrm>
-          <a:prstGeom prst="rect">
-            <a:avLst/>
-          </a:prstGeom>
-        </p:spPr>
-      </p:pic>
-      <p:sp>
-        <p:nvSpPr>
-          <p:cNvPr id="10" name="TextBox 9">
-            <a:extLst>
-              <a:ext uri="{FF2B5EF4-FFF2-40B4-BE49-F238E27FC236}">
-                <a16:creationId xmlns:a16="http://schemas.microsoft.com/office/drawing/2014/main" id="{8E7C95CC-2585-95F4-F078-4DC6534EB4AC}"/>
-              </a:ext>
-            </a:extLst>
-          </p:cNvPr>
-          <p:cNvSpPr txBox="1"/>
-          <p:nvPr/>
-        </p:nvSpPr>
-        <p:spPr>
-          <a:xfrm>
-            <a:off x="762000" y="5969000"/>
-            <a:ext cx="10668000" cy="345440"/>
-          </a:xfrm>
-          <a:prstGeom prst="rect">
-            <a:avLst/>
-          </a:prstGeom>
-          <a:noFill/>
-        </p:spPr>
-        <p:txBody>
-          <a:bodyPr vert="horz" wrap="square" rtlCol="0">
-            <a:noAutofit/>
-          </a:bodyPr>
-          <a:lstStyle/>
-          <a:p>
-            <a:r>
-              <a:rPr lang="en-US" sz="1600">
-                <a:solidFill>
-                  <a:srgbClr val="000000"/>
-                </a:solidFill>
-              </a:rPr>
-              <a:t>Works like an SRS - unless the list has a repeating pattern that lines up with k</a:t>
-            </a:r>
-          </a:p>
-        </p:txBody>
-      </p:sp>
-      <p:sp>
-        <p:nvSpPr>
-          <p:cNvPr id="3" name="Title rule">
-            <a:extLst>
-              <a:ext uri="{FF2B5EF4-FFF2-40B4-BE49-F238E27FC236}">
-                <a16:creationId xmlns:a16="http://schemas.microsoft.com/office/drawing/2014/main" id="{2F33DF17-F38C-5CEA-9FDD-F067BB8A13EF}"/>
-              </a:ext>
-            </a:extLst>
-          </p:cNvPr>
-          <p:cNvSpPr/>
-          <p:nvPr/>
-        </p:nvSpPr>
-        <p:spPr>
-          <a:xfrm>
-            <a:off x="838200" y="1600200"/>
-            <a:ext cx="10515600" cy="38100"/>
-          </a:xfrm>
-          <a:prstGeom prst="rect">
-            <a:avLst/>
-          </a:prstGeom>
-          <a:solidFill>
-            <a:srgbClr val="4472C4"/>
-          </a:solidFill>
-          <a:ln w="12700" cap="flat" cmpd="sng" algn="ctr">
-            <a:noFill/>
-            <a:prstDash val="solid"/>
-            <a:miter lim="800000"/>
-          </a:ln>
-          <a:effectLst/>
-          <a:extLst>
-            <a:ext uri="{91240B29-F687-4F45-9708-019B960494DF}">
-              <a14:hiddenLine xmlns:a14="http://schemas.microsoft.com/office/drawing/2010/main" w="12700" cap="flat" cmpd="sng" algn="ctr">
-                <a:solidFill>
-                  <a:schemeClr val="accent1">
-                    <a:shade val="15000"/>
-                  </a:schemeClr>
-                </a:solidFill>
-                <a:prstDash val="solid"/>
-                <a:miter lim="800000"/>
-              </a14:hiddenLine>
-            </a:ext>
-          </a:extLst>
-        </p:spPr>
-        <p:style>
-          <a:lnRef idx="2">
-            <a:schemeClr val="accent1">
-              <a:shade val="15000"/>
-            </a:schemeClr>
-          </a:lnRef>
-          <a:fillRef idx="1">
-            <a:schemeClr val="accent1"/>
-          </a:fillRef>
-          <a:effectRef idx="0">
-            <a:schemeClr val="accent1"/>
-          </a:effectRef>
-          <a:fontRef idx="minor">
-            <a:schemeClr val="lt1"/>
-          </a:fontRef>
-        </p:style>
-        <p:txBody>
-          <a:bodyPr rtlCol="0" anchor="ctr"/>
-          <a:lstStyle/>
-          <a:p>
-            <a:pPr algn="ctr"/>
-            <a:endParaRPr lang="en-US"/>
-          </a:p>
-        </p:txBody>
-      </p:sp>
-    </p:spTree>
-    <p:extLst>
-      <p:ext uri="{BB962C8B-B14F-4D97-AF65-F5344CB8AC3E}">
-        <p14:creationId xmlns:p14="http://schemas.microsoft.com/office/powerpoint/2010/main" val="2965809799"/>
-      </p:ext>
-    </p:extLst>
-  </p:cSld>
-  <p:clrMapOvr>
-    <a:masterClrMapping/>
-  </p:clrMapOvr>
-  <p:timing>
-    <p:tnLst>
-      <p:par>
-        <p:cTn id="1" dur="indefinite" restart="never" nodeType="tmRoot">
-          <p:childTnLst>
-            <p:seq concurrent="1" nextAc="seek">
-              <p:cTn id="2" dur="indefinite" nodeType="mainSeq">
-                <p:childTnLst>
-                  <p:par>
-                    <p:cTn id="3" fill="hold">
-                      <p:stCondLst>
-                        <p:cond delay="indefinite"/>
-                      </p:stCondLst>
-                      <p:childTnLst>
-                        <p:par>
-                          <p:cTn id="4" fill="hold">
-                            <p:stCondLst>
-                              <p:cond delay="0"/>
-                            </p:stCondLst>
-                            <p:childTnLst>
-                              <p:par>
-                                <p:cTn id="5" presetID="34" presetClass="entr" presetSubtype="0" fill="hold" grpId="0" nodeType="clickEffect">
-                                  <p:stCondLst>
-                                    <p:cond delay="0"/>
-                                  </p:stCondLst>
-                                  <p:childTnLst>
-                                    <p:set>
-                                      <p:cBhvr>
-                                        <p:cTn id="6" dur="1" fill="hold">
-                                          <p:stCondLst>
-                                            <p:cond delay="0"/>
-                                          </p:stCondLst>
-                                        </p:cTn>
-                                        <p:tgtEl>
-                                          <p:spTgt spid="6"/>
-                                        </p:tgtEl>
-                                        <p:attrNameLst>
-                                          <p:attrName>style.visibility</p:attrName>
-                                        </p:attrNameLst>
-                                      </p:cBhvr>
-                                      <p:to>
-                                        <p:strVal val="visible"/>
-                                      </p:to>
-                                    </p:set>
-                                    <p:anim from="(-#ppt_w/2)" to="(#ppt_x)" calcmode="lin" valueType="num">
-                                      <p:cBhvr>
-                                        <p:cTn id="7" dur="600" fill="hold">
-                                          <p:stCondLst>
-                                            <p:cond delay="0"/>
-                                          </p:stCondLst>
-                                        </p:cTn>
-                                        <p:tgtEl>
-                                          <p:spTgt spid="6"/>
-                                        </p:tgtEl>
-                                        <p:attrNameLst>
-                                          <p:attrName>ppt_x</p:attrName>
-                                        </p:attrNameLst>
-                                      </p:cBhvr>
-                                    </p:anim>
-                                    <p:anim from="0" to="-1.0" calcmode="lin" valueType="num">
-                                      <p:cBhvr>
-                                        <p:cTn id="8" dur="200" decel="50000" autoRev="1" fill="hold">
-                                          <p:stCondLst>
-                                            <p:cond delay="600"/>
-                                          </p:stCondLst>
-                                        </p:cTn>
-                                        <p:tgtEl>
-                                          <p:spTgt spid="6"/>
-                                        </p:tgtEl>
-                                        <p:attrNameLst>
-                                          <p:attrName>xshear</p:attrName>
-                                        </p:attrNameLst>
-                                      </p:cBhvr>
-                                    </p:anim>
-                                    <p:animScale>
-                                      <p:cBhvr>
-                                        <p:cTn id="9" dur="200" decel="100000" autoRev="1" fill="hold">
-                                          <p:stCondLst>
-                                            <p:cond delay="600"/>
-                                          </p:stCondLst>
-                                        </p:cTn>
-                                        <p:tgtEl>
-                                          <p:spTgt spid="6"/>
-                                        </p:tgtEl>
-                                      </p:cBhvr>
-                                      <p:from x="100000" y="100000"/>
-                                      <p:to x="80000" y="100000"/>
-                                    </p:animScale>
-                                    <p:anim by="(#ppt_h/3+#ppt_w*0.1)" calcmode="lin" valueType="num">
-                                      <p:cBhvr additive="sum">
-                                        <p:cTn id="10" dur="200" decel="100000" autoRev="1" fill="hold">
-                                          <p:stCondLst>
-                                            <p:cond delay="600"/>
-                                          </p:stCondLst>
-                                        </p:cTn>
-                                        <p:tgtEl>
-                                          <p:spTgt spid="6"/>
-                                        </p:tgtEl>
-                                        <p:attrNameLst>
-                                          <p:attrName>ppt_x</p:attrName>
-                                        </p:attrNameLst>
-                                      </p:cBhvr>
-                                    </p:anim>
-                                  </p:childTnLst>
-                                </p:cTn>
-                              </p:par>
-                            </p:childTnLst>
-                          </p:cTn>
-                        </p:par>
-                      </p:childTnLst>
-                    </p:cTn>
-                  </p:par>
-                  <p:par>
-                    <p:cTn id="11" fill="hold">
-                      <p:stCondLst>
-                        <p:cond delay="indefinite"/>
-                      </p:stCondLst>
-                      <p:childTnLst>
-                        <p:par>
-                          <p:cTn id="12" fill="hold">
-                            <p:stCondLst>
-                              <p:cond delay="0"/>
-                            </p:stCondLst>
-                            <p:childTnLst>
-                              <p:par>
-                                <p:cTn id="13" presetID="34" presetClass="entr" presetSubtype="0" fill="hold" grpId="0" nodeType="clickEffect">
-                                  <p:stCondLst>
-                                    <p:cond delay="0"/>
-                                  </p:stCondLst>
-                                  <p:childTnLst>
-                                    <p:set>
-                                      <p:cBhvr>
-                                        <p:cTn id="14" dur="1" fill="hold">
-                                          <p:stCondLst>
-                                            <p:cond delay="0"/>
-                                          </p:stCondLst>
-                                        </p:cTn>
-                                        <p:tgtEl>
-                                          <p:spTgt spid="7"/>
-                                        </p:tgtEl>
-                                        <p:attrNameLst>
-                                          <p:attrName>style.visibility</p:attrName>
-                                        </p:attrNameLst>
-                                      </p:cBhvr>
-                                      <p:to>
-                                        <p:strVal val="visible"/>
-                                      </p:to>
-                                    </p:set>
-                                    <p:anim from="(-#ppt_w/2)" to="(#ppt_x)" calcmode="lin" valueType="num">
-                                      <p:cBhvr>
-                                        <p:cTn id="15" dur="600" fill="hold">
-                                          <p:stCondLst>
-                                            <p:cond delay="0"/>
-                                          </p:stCondLst>
-                                        </p:cTn>
-                                        <p:tgtEl>
-                                          <p:spTgt spid="7"/>
-                                        </p:tgtEl>
-                                        <p:attrNameLst>
-                                          <p:attrName>ppt_x</p:attrName>
-                                        </p:attrNameLst>
-                                      </p:cBhvr>
-                                    </p:anim>
-                                    <p:anim from="0" to="-1.0" calcmode="lin" valueType="num">
-                                      <p:cBhvr>
-                                        <p:cTn id="16" dur="200" decel="50000" autoRev="1" fill="hold">
-                                          <p:stCondLst>
-                                            <p:cond delay="600"/>
-                                          </p:stCondLst>
-                                        </p:cTn>
-                                        <p:tgtEl>
-                                          <p:spTgt spid="7"/>
-                                        </p:tgtEl>
-                                        <p:attrNameLst>
-                                          <p:attrName>xshear</p:attrName>
-                                        </p:attrNameLst>
-                                      </p:cBhvr>
-                                    </p:anim>
-                                    <p:animScale>
-                                      <p:cBhvr>
-                                        <p:cTn id="17" dur="200" decel="100000" autoRev="1" fill="hold">
-                                          <p:stCondLst>
-                                            <p:cond delay="600"/>
-                                          </p:stCondLst>
-                                        </p:cTn>
-                                        <p:tgtEl>
-                                          <p:spTgt spid="7"/>
-                                        </p:tgtEl>
-                                      </p:cBhvr>
-                                      <p:from x="100000" y="100000"/>
-                                      <p:to x="80000" y="100000"/>
-                                    </p:animScale>
-                                    <p:anim by="(#ppt_h/3+#ppt_w*0.1)" calcmode="lin" valueType="num">
-                                      <p:cBhvr additive="sum">
-                                        <p:cTn id="18" dur="200" decel="100000" autoRev="1" fill="hold">
-                                          <p:stCondLst>
-                                            <p:cond delay="600"/>
-                                          </p:stCondLst>
-                                        </p:cTn>
-                                        <p:tgtEl>
-                                          <p:spTgt spid="7"/>
-                                        </p:tgtEl>
-                                        <p:attrNameLst>
-                                          <p:attrName>ppt_x</p:attrName>
-                                        </p:attrNameLst>
-                                      </p:cBhvr>
-                                    </p:anim>
-                                  </p:childTnLst>
-                                </p:cTn>
-                              </p:par>
-                            </p:childTnLst>
-                          </p:cTn>
-                        </p:par>
-                      </p:childTnLst>
-                    </p:cTn>
-                  </p:par>
-                  <p:par>
-                    <p:cTn id="19" fill="hold">
-                      <p:stCondLst>
-                        <p:cond delay="indefinite"/>
-                      </p:stCondLst>
-                      <p:childTnLst>
-                        <p:par>
-                          <p:cTn id="20" fill="hold">
-                            <p:stCondLst>
-                              <p:cond delay="0"/>
-                            </p:stCondLst>
-                            <p:childTnLst>
-                              <p:par>
-                                <p:cTn id="21" presetID="34" presetClass="entr" presetSubtype="0" fill="hold" grpId="0" nodeType="clickEffect">
-                                  <p:stCondLst>
-                                    <p:cond delay="0"/>
-                                  </p:stCondLst>
-                                  <p:childTnLst>
-                                    <p:set>
-                                      <p:cBhvr>
-                                        <p:cTn id="22" dur="1" fill="hold">
-                                          <p:stCondLst>
-                                            <p:cond delay="0"/>
-                                          </p:stCondLst>
-                                        </p:cTn>
-                                        <p:tgtEl>
-                                          <p:spTgt spid="10"/>
-                                        </p:tgtEl>
-                                        <p:attrNameLst>
-                                          <p:attrName>style.visibility</p:attrName>
-                                        </p:attrNameLst>
-                                      </p:cBhvr>
-                                      <p:to>
-                                        <p:strVal val="visible"/>
-                                      </p:to>
-                                    </p:set>
-                                    <p:anim from="(-#ppt_w/2)" to="(#ppt_x)" calcmode="lin" valueType="num">
-                                      <p:cBhvr>
-                                        <p:cTn id="23" dur="600" fill="hold">
-                                          <p:stCondLst>
-                                            <p:cond delay="0"/>
-                                          </p:stCondLst>
-                                        </p:cTn>
-                                        <p:tgtEl>
-                                          <p:spTgt spid="10"/>
-                                        </p:tgtEl>
-                                        <p:attrNameLst>
-                                          <p:attrName>ppt_x</p:attrName>
-                                        </p:attrNameLst>
-                                      </p:cBhvr>
-                                    </p:anim>
-                                    <p:anim from="0" to="-1.0" calcmode="lin" valueType="num">
-                                      <p:cBhvr>
-                                        <p:cTn id="24" dur="200" decel="50000" autoRev="1" fill="hold">
-                                          <p:stCondLst>
-                                            <p:cond delay="600"/>
-                                          </p:stCondLst>
-                                        </p:cTn>
-                                        <p:tgtEl>
-                                          <p:spTgt spid="10"/>
-                                        </p:tgtEl>
-                                        <p:attrNameLst>
-                                          <p:attrName>xshear</p:attrName>
-                                        </p:attrNameLst>
-                                      </p:cBhvr>
-                                    </p:anim>
-                                    <p:animScale>
-                                      <p:cBhvr>
-                                        <p:cTn id="25" dur="200" decel="100000" autoRev="1" fill="hold">
-                                          <p:stCondLst>
-                                            <p:cond delay="600"/>
-                                          </p:stCondLst>
-                                        </p:cTn>
-                                        <p:tgtEl>
-                                          <p:spTgt spid="10"/>
-                                        </p:tgtEl>
-                                      </p:cBhvr>
-                                      <p:from x="100000" y="100000"/>
-                                      <p:to x="80000" y="100000"/>
-                                    </p:animScale>
-                                    <p:anim by="(#ppt_h/3+#ppt_w*0.1)" calcmode="lin" valueType="num">
-                                      <p:cBhvr additive="sum">
-                                        <p:cTn id="26" dur="200" decel="100000" autoRev="1" fill="hold">
-                                          <p:stCondLst>
-                                            <p:cond delay="600"/>
-                                          </p:stCondLst>
-                                        </p:cTn>
-                                        <p:tgtEl>
-                                          <p:spTgt spid="10"/>
-                                        </p:tgtEl>
-                                        <p:attrNameLst>
-                                          <p:attrName>ppt_x</p:attrName>
-                                        </p:attrNameLst>
-                                      </p:cBhvr>
-                                    </p:anim>
-                                  </p:childTnLst>
-                                </p:cTn>
-                              </p:par>
-                            </p:childTnLst>
-                          </p:cTn>
-                        </p:par>
-                      </p:childTnLst>
-                    </p:cTn>
-                  </p:par>
-                </p:childTnLst>
-              </p:cTn>
-              <p:prevCondLst>
-                <p:cond evt="onPrev" delay="0">
-                  <p:tgtEl>
-                    <p:sldTgt/>
-                  </p:tgtEl>
-                </p:cond>
-              </p:prevCondLst>
-              <p:nextCondLst>
-                <p:cond evt="onNext" delay="0">
-                  <p:tgtEl>
-                    <p:sldTgt/>
-                  </p:tgtEl>
-                </p:cond>
-              </p:nextCondLst>
-            </p:seq>
-          </p:childTnLst>
-        </p:cTn>
-      </p:par>
-    </p:tnLst>
-    <p:bldLst>
-      <p:bldP spid="6" grpId="0"/>
-      <p:bldP spid="7" grpId="0"/>
-      <p:bldP spid="10" grpId="0"/>
-    </p:bldLst>
-  </p:timing>
-</p:sld>
-</file>
-
-<file path=ppt/slides/slide22.xml><?xml version="1.0" encoding="utf-8"?>
-<p:sld xmlns:a="http://schemas.openxmlformats.org/drawingml/2006/main" xmlns:r="http://schemas.openxmlformats.org/officeDocument/2006/relationships" xmlns:p="http://schemas.openxmlformats.org/presentationml/2006/main">
-  <p:cSld>
-    <p:spTree>
-      <p:nvGrpSpPr>
-        <p:cNvPr id="1" name=""/>
-        <p:cNvGrpSpPr/>
-        <p:nvPr/>
-      </p:nvGrpSpPr>
-      <p:grpSpPr>
-        <a:xfrm>
-          <a:off x="0" y="0"/>
-          <a:ext cx="0" cy="0"/>
-          <a:chOff x="0" y="0"/>
-          <a:chExt cx="0" cy="0"/>
-        </a:xfrm>
-      </p:grpSpPr>
-      <p:sp>
-        <p:nvSpPr>
-          <p:cNvPr id="2" name="Title 1">
-            <a:extLst>
-              <a:ext uri="{FF2B5EF4-FFF2-40B4-BE49-F238E27FC236}">
-                <a16:creationId xmlns:a16="http://schemas.microsoft.com/office/drawing/2014/main" id="{B416E805-04AC-8627-66AE-26DA578A838E}"/>
-              </a:ext>
-            </a:extLst>
-          </p:cNvPr>
-          <p:cNvSpPr>
-            <a:spLocks noGrp="1"/>
-          </p:cNvSpPr>
-          <p:nvPr>
-            <p:ph type="title"/>
-          </p:nvPr>
-        </p:nvSpPr>
-        <p:spPr/>
-        <p:txBody>
-          <a:bodyPr>
-            <a:noAutofit/>
-          </a:bodyPr>
-          <a:lstStyle/>
-          <a:p>
-            <a:r>
-              <a:rPr lang="en-US">
-                <a:solidFill>
-                  <a:srgbClr val="1F3864"/>
-                </a:solidFill>
-              </a:rPr>
-              <a:t>Stratified random sample</a:t>
-            </a:r>
-          </a:p>
-        </p:txBody>
-      </p:sp>
-      <p:sp>
-        <p:nvSpPr>
-          <p:cNvPr id="4" name="Slide Number Placeholder 3">
-            <a:extLst>
-              <a:ext uri="{FF2B5EF4-FFF2-40B4-BE49-F238E27FC236}">
-                <a16:creationId xmlns:a16="http://schemas.microsoft.com/office/drawing/2014/main" id="{C98406A2-7F5B-24F5-5E49-5056AD0D2BF2}"/>
-              </a:ext>
-            </a:extLst>
-          </p:cNvPr>
-          <p:cNvSpPr>
-            <a:spLocks noGrp="1"/>
-          </p:cNvSpPr>
-          <p:nvPr>
-            <p:ph type="sldNum" sz="quarter" idx="12"/>
-          </p:nvPr>
-        </p:nvSpPr>
-        <p:spPr/>
-        <p:txBody>
-          <a:bodyPr/>
-          <a:lstStyle/>
-          <a:p>
-            <a:fld id="{A80A81DD-F10A-4B1C-963A-0ABBB4865886}" type="slidenum">
-              <a:rPr lang="en-US" sz="1600" smtClean="0"/>
-              <a:t>22</a:t>
-            </a:fld>
-            <a:endParaRPr lang="en-US" sz="1600"/>
-          </a:p>
-        </p:txBody>
-      </p:sp>
-      <p:sp>
-        <p:nvSpPr>
-          <p:cNvPr id="5" name="TextBox 4">
-            <a:extLst>
-              <a:ext uri="{FF2B5EF4-FFF2-40B4-BE49-F238E27FC236}">
-                <a16:creationId xmlns:a16="http://schemas.microsoft.com/office/drawing/2014/main" id="{A6A2458B-0AA1-E8C9-39EE-CA982E9119F6}"/>
-              </a:ext>
-            </a:extLst>
-          </p:cNvPr>
-          <p:cNvSpPr txBox="1"/>
-          <p:nvPr/>
-        </p:nvSpPr>
-        <p:spPr>
-          <a:xfrm>
-            <a:off x="571500" y="1841500"/>
-            <a:ext cx="6223000" cy="345440"/>
-          </a:xfrm>
-          <a:prstGeom prst="rect">
-            <a:avLst/>
-          </a:prstGeom>
-          <a:noFill/>
-        </p:spPr>
-        <p:txBody>
-          <a:bodyPr vert="horz" wrap="square" rtlCol="0">
-            <a:noAutofit/>
-          </a:bodyPr>
-          <a:lstStyle/>
-          <a:p>
-            <a:r>
-              <a:rPr lang="en-US" sz="1600" b="1">
-                <a:solidFill>
-                  <a:srgbClr val="C00000"/>
-                </a:solidFill>
-              </a:rPr>
-              <a:t>strata</a:t>
-            </a:r>
-          </a:p>
-        </p:txBody>
-      </p:sp>
-      <p:sp>
-        <p:nvSpPr>
-          <p:cNvPr id="6" name="TextBox 5">
-            <a:extLst>
-              <a:ext uri="{FF2B5EF4-FFF2-40B4-BE49-F238E27FC236}">
-                <a16:creationId xmlns:a16="http://schemas.microsoft.com/office/drawing/2014/main" id="{EF435368-2E5B-AF0E-01AC-9C12A4355760}"/>
-              </a:ext>
-            </a:extLst>
-          </p:cNvPr>
-          <p:cNvSpPr txBox="1"/>
-          <p:nvPr/>
-        </p:nvSpPr>
-        <p:spPr>
-          <a:xfrm>
-            <a:off x="850900" y="2110739"/>
-            <a:ext cx="5943600" cy="589280"/>
-          </a:xfrm>
-          <a:prstGeom prst="rect">
-            <a:avLst/>
-          </a:prstGeom>
-          <a:noFill/>
-        </p:spPr>
-        <p:txBody>
-          <a:bodyPr vert="horz" wrap="square" rtlCol="0">
-            <a:noAutofit/>
-          </a:bodyPr>
-          <a:lstStyle/>
-          <a:p>
-            <a:r>
-              <a:rPr lang="en-US" sz="1600">
-                <a:solidFill>
-                  <a:srgbClr val="000000"/>
-                </a:solidFill>
-              </a:rPr>
-              <a:t>groups of units that are alike, formed BEFORE sampling - class year, region, age group</a:t>
-            </a:r>
-          </a:p>
-        </p:txBody>
-      </p:sp>
-      <p:sp>
-        <p:nvSpPr>
-          <p:cNvPr id="7" name="TextBox 6">
-            <a:extLst>
-              <a:ext uri="{FF2B5EF4-FFF2-40B4-BE49-F238E27FC236}">
-                <a16:creationId xmlns:a16="http://schemas.microsoft.com/office/drawing/2014/main" id="{49490EB5-C42D-BF95-5B7C-4469ECC019FC}"/>
-              </a:ext>
-            </a:extLst>
-          </p:cNvPr>
-          <p:cNvSpPr txBox="1"/>
-          <p:nvPr/>
-        </p:nvSpPr>
-        <p:spPr>
-          <a:xfrm>
-            <a:off x="571500" y="2776220"/>
-            <a:ext cx="6223000" cy="345440"/>
-          </a:xfrm>
-          <a:prstGeom prst="rect">
-            <a:avLst/>
-          </a:prstGeom>
-          <a:noFill/>
-        </p:spPr>
-        <p:txBody>
-          <a:bodyPr vert="horz" wrap="square" rtlCol="0">
-            <a:noAutofit/>
-          </a:bodyPr>
-          <a:lstStyle/>
-          <a:p>
-            <a:r>
-              <a:rPr lang="en-US" sz="1600" b="1">
-                <a:solidFill>
-                  <a:srgbClr val="C00000"/>
-                </a:solidFill>
-              </a:rPr>
-              <a:t>stratified random sample</a:t>
-            </a:r>
-          </a:p>
-        </p:txBody>
-      </p:sp>
-      <p:sp>
-        <p:nvSpPr>
-          <p:cNvPr id="8" name="TextBox 7">
-            <a:extLst>
-              <a:ext uri="{FF2B5EF4-FFF2-40B4-BE49-F238E27FC236}">
-                <a16:creationId xmlns:a16="http://schemas.microsoft.com/office/drawing/2014/main" id="{BEF5BCF9-8285-D541-7330-1790862F3580}"/>
-              </a:ext>
-            </a:extLst>
-          </p:cNvPr>
-          <p:cNvSpPr txBox="1"/>
-          <p:nvPr/>
-        </p:nvSpPr>
-        <p:spPr>
-          <a:xfrm>
-            <a:off x="850900" y="3045460"/>
-            <a:ext cx="5943600" cy="345440"/>
-          </a:xfrm>
-          <a:prstGeom prst="rect">
-            <a:avLst/>
-          </a:prstGeom>
-          <a:noFill/>
-        </p:spPr>
-        <p:txBody>
-          <a:bodyPr vert="horz" wrap="square" rtlCol="0">
-            <a:noAutofit/>
-          </a:bodyPr>
-          <a:lstStyle/>
-          <a:p>
-            <a:r>
-              <a:rPr lang="en-US" sz="1600">
-                <a:solidFill>
-                  <a:srgbClr val="000000"/>
-                </a:solidFill>
-              </a:rPr>
-              <a:t>a separate SRS inside every stratum, combined into one sample</a:t>
-            </a:r>
-          </a:p>
-        </p:txBody>
-      </p:sp>
-      <p:sp>
-        <p:nvSpPr>
-          <p:cNvPr id="9" name="TextBox 8">
-            <a:extLst>
-              <a:ext uri="{FF2B5EF4-FFF2-40B4-BE49-F238E27FC236}">
-                <a16:creationId xmlns:a16="http://schemas.microsoft.com/office/drawing/2014/main" id="{73FFC2DD-65F2-EFF3-93FB-D22279D7CC17}"/>
-              </a:ext>
-            </a:extLst>
-          </p:cNvPr>
-          <p:cNvSpPr txBox="1"/>
-          <p:nvPr/>
-        </p:nvSpPr>
-        <p:spPr>
-          <a:xfrm>
-            <a:off x="571500" y="3467100"/>
-            <a:ext cx="6223000" cy="345440"/>
-          </a:xfrm>
-          <a:prstGeom prst="rect">
-            <a:avLst/>
-          </a:prstGeom>
-          <a:noFill/>
-        </p:spPr>
-        <p:txBody>
-          <a:bodyPr vert="horz" wrap="square" rtlCol="0">
-            <a:noAutofit/>
-          </a:bodyPr>
-          <a:lstStyle/>
-          <a:p>
-            <a:r>
-              <a:rPr lang="en-US" sz="1600" b="1">
-                <a:solidFill>
-                  <a:srgbClr val="C00000"/>
-                </a:solidFill>
-              </a:rPr>
-              <a:t>proportional allocation</a:t>
-            </a:r>
-          </a:p>
-        </p:txBody>
-      </p:sp>
-      <p:sp>
-        <p:nvSpPr>
-          <p:cNvPr id="10" name="TextBox 9">
-            <a:extLst>
-              <a:ext uri="{FF2B5EF4-FFF2-40B4-BE49-F238E27FC236}">
-                <a16:creationId xmlns:a16="http://schemas.microsoft.com/office/drawing/2014/main" id="{DD562EC6-6104-9EFC-9213-8793181910F3}"/>
-              </a:ext>
-            </a:extLst>
-          </p:cNvPr>
-          <p:cNvSpPr txBox="1"/>
-          <p:nvPr/>
-        </p:nvSpPr>
-        <p:spPr>
-          <a:xfrm>
-            <a:off x="850900" y="3736340"/>
-            <a:ext cx="5943600" cy="345440"/>
-          </a:xfrm>
-          <a:prstGeom prst="rect">
-            <a:avLst/>
-          </a:prstGeom>
-          <a:noFill/>
-        </p:spPr>
-        <p:txBody>
-          <a:bodyPr vert="horz" wrap="square" rtlCol="0">
-            <a:noAutofit/>
-          </a:bodyPr>
-          <a:lstStyle/>
-          <a:p>
-            <a:r>
-              <a:rPr lang="en-US" sz="1600">
-                <a:solidFill>
-                  <a:srgbClr val="000000"/>
-                </a:solidFill>
-              </a:rPr>
-              <a:t>each stratum gets its share of n: 40, 30, 20, 10 students -&gt; 8, 6, 4, 2</a:t>
-            </a:r>
-          </a:p>
-        </p:txBody>
-      </p:sp>
-      <p:sp>
-        <p:nvSpPr>
-          <p:cNvPr id="11" name="TextBox 10">
-            <a:extLst>
-              <a:ext uri="{FF2B5EF4-FFF2-40B4-BE49-F238E27FC236}">
-                <a16:creationId xmlns:a16="http://schemas.microsoft.com/office/drawing/2014/main" id="{377D03EC-98B8-EFA6-7B19-7ACF3DF1AE45}"/>
-              </a:ext>
-            </a:extLst>
-          </p:cNvPr>
-          <p:cNvSpPr txBox="1"/>
-          <p:nvPr/>
-        </p:nvSpPr>
-        <p:spPr>
-          <a:xfrm>
-            <a:off x="571500" y="4157980"/>
-            <a:ext cx="6223000" cy="345440"/>
-          </a:xfrm>
-          <a:prstGeom prst="rect">
-            <a:avLst/>
-          </a:prstGeom>
-          <a:noFill/>
-        </p:spPr>
-        <p:txBody>
-          <a:bodyPr vert="horz" wrap="square" rtlCol="0">
-            <a:noAutofit/>
-          </a:bodyPr>
-          <a:lstStyle/>
-          <a:p>
-            <a:r>
-              <a:rPr lang="en-US" sz="1600" b="1">
-                <a:solidFill>
-                  <a:srgbClr val="1F3864"/>
-                </a:solidFill>
-              </a:rPr>
-              <a:t>Every group is guaranteed a place - no more 2 juniors by bad luck</a:t>
-            </a:r>
-          </a:p>
-        </p:txBody>
-      </p:sp>
-      <p:pic>
-        <p:nvPicPr>
-          <p:cNvPr id="13" name="l8_design_stratified.png">
-            <a:extLst>
-              <a:ext uri="{FF2B5EF4-FFF2-40B4-BE49-F238E27FC236}">
-                <a16:creationId xmlns:a16="http://schemas.microsoft.com/office/drawing/2014/main" id="{178531D0-F711-51C4-33D6-2FDDC352EC94}"/>
-              </a:ext>
-            </a:extLst>
-          </p:cNvPr>
-          <p:cNvPicPr>
-            <a:picLocks/>
-          </p:cNvPicPr>
-          <p:nvPr/>
-        </p:nvPicPr>
-        <p:blipFill>
-          <a:blip r:embed="rId2">
-            <a:extLst>
-              <a:ext uri="{28A0092B-C50C-407E-A947-70E740481C1C}">
-                <a14:useLocalDpi xmlns:a14="http://schemas.microsoft.com/office/drawing/2010/main" val="0"/>
-              </a:ext>
-            </a:extLst>
-          </a:blip>
-          <a:stretch>
-            <a:fillRect/>
-          </a:stretch>
-        </p:blipFill>
-        <p:spPr>
-          <a:xfrm>
-            <a:off x="7112000" y="1778000"/>
-            <a:ext cx="4572000" cy="4572000"/>
-          </a:xfrm>
-          <a:prstGeom prst="rect">
-            <a:avLst/>
-          </a:prstGeom>
-        </p:spPr>
-      </p:pic>
-      <p:sp>
-        <p:nvSpPr>
-          <p:cNvPr id="3" name="Title rule">
-            <a:extLst>
-              <a:ext uri="{FF2B5EF4-FFF2-40B4-BE49-F238E27FC236}">
-                <a16:creationId xmlns:a16="http://schemas.microsoft.com/office/drawing/2014/main" id="{E7A1A481-EFE9-E2B6-2D31-F3B3EDED8C66}"/>
-              </a:ext>
-            </a:extLst>
-          </p:cNvPr>
-          <p:cNvSpPr/>
-          <p:nvPr/>
-        </p:nvSpPr>
-        <p:spPr>
-          <a:xfrm>
-            <a:off x="838200" y="1600200"/>
-            <a:ext cx="10515600" cy="38100"/>
-          </a:xfrm>
-          <a:prstGeom prst="rect">
-            <a:avLst/>
-          </a:prstGeom>
-          <a:solidFill>
-            <a:srgbClr val="4472C4"/>
-          </a:solidFill>
-          <a:ln w="12700" cap="flat" cmpd="sng" algn="ctr">
-            <a:noFill/>
-            <a:prstDash val="solid"/>
-            <a:miter lim="800000"/>
-          </a:ln>
-          <a:effectLst/>
-          <a:extLst>
-            <a:ext uri="{91240B29-F687-4F45-9708-019B960494DF}">
-              <a14:hiddenLine xmlns:a14="http://schemas.microsoft.com/office/drawing/2010/main" w="12700" cap="flat" cmpd="sng" algn="ctr">
-                <a:solidFill>
-                  <a:schemeClr val="accent1">
-                    <a:shade val="15000"/>
-                  </a:schemeClr>
-                </a:solidFill>
-                <a:prstDash val="solid"/>
-                <a:miter lim="800000"/>
-              </a14:hiddenLine>
-            </a:ext>
-          </a:extLst>
-        </p:spPr>
-        <p:style>
-          <a:lnRef idx="2">
-            <a:schemeClr val="accent1">
-              <a:shade val="15000"/>
-            </a:schemeClr>
-          </a:lnRef>
-          <a:fillRef idx="1">
-            <a:schemeClr val="accent1"/>
-          </a:fillRef>
-          <a:effectRef idx="0">
-            <a:schemeClr val="accent1"/>
-          </a:effectRef>
-          <a:fontRef idx="minor">
-            <a:schemeClr val="lt1"/>
-          </a:fontRef>
-        </p:style>
-        <p:txBody>
-          <a:bodyPr rtlCol="0" anchor="ctr"/>
-          <a:lstStyle/>
-          <a:p>
-            <a:pPr algn="ctr"/>
-            <a:endParaRPr lang="en-US"/>
-          </a:p>
-        </p:txBody>
-      </p:sp>
-    </p:spTree>
-    <p:extLst>
-      <p:ext uri="{BB962C8B-B14F-4D97-AF65-F5344CB8AC3E}">
-        <p14:creationId xmlns:p14="http://schemas.microsoft.com/office/powerpoint/2010/main" val="918706645"/>
-      </p:ext>
-    </p:extLst>
-  </p:cSld>
-  <p:clrMapOvr>
-    <a:masterClrMapping/>
-  </p:clrMapOvr>
-  <p:timing>
-    <p:tnLst>
-      <p:par>
-        <p:cTn id="1" dur="indefinite" restart="never" nodeType="tmRoot">
-          <p:childTnLst>
-            <p:seq concurrent="1" nextAc="seek">
-              <p:cTn id="2" dur="indefinite" nodeType="mainSeq">
-                <p:childTnLst>
-                  <p:par>
-                    <p:cTn id="3" fill="hold">
-                      <p:stCondLst>
-                        <p:cond delay="indefinite"/>
-                      </p:stCondLst>
-                      <p:childTnLst>
-                        <p:par>
-                          <p:cTn id="4" fill="hold">
-                            <p:stCondLst>
-                              <p:cond delay="0"/>
-                            </p:stCondLst>
-                            <p:childTnLst>
-                              <p:par>
-                                <p:cTn id="5" presetID="34" presetClass="entr" presetSubtype="0" fill="hold" grpId="0" nodeType="clickEffect">
-                                  <p:stCondLst>
-                                    <p:cond delay="0"/>
-                                  </p:stCondLst>
-                                  <p:childTnLst>
-                                    <p:set>
-                                      <p:cBhvr>
-                                        <p:cTn id="6" dur="1" fill="hold">
-                                          <p:stCondLst>
-                                            <p:cond delay="0"/>
-                                          </p:stCondLst>
-                                        </p:cTn>
-                                        <p:tgtEl>
-                                          <p:spTgt spid="6"/>
-                                        </p:tgtEl>
-                                        <p:attrNameLst>
-                                          <p:attrName>style.visibility</p:attrName>
-                                        </p:attrNameLst>
-                                      </p:cBhvr>
-                                      <p:to>
-                                        <p:strVal val="visible"/>
-                                      </p:to>
-                                    </p:set>
-                                    <p:anim from="(-#ppt_w/2)" to="(#ppt_x)" calcmode="lin" valueType="num">
-                                      <p:cBhvr>
-                                        <p:cTn id="7" dur="600" fill="hold">
-                                          <p:stCondLst>
-                                            <p:cond delay="0"/>
-                                          </p:stCondLst>
-                                        </p:cTn>
-                                        <p:tgtEl>
-                                          <p:spTgt spid="6"/>
-                                        </p:tgtEl>
-                                        <p:attrNameLst>
-                                          <p:attrName>ppt_x</p:attrName>
-                                        </p:attrNameLst>
-                                      </p:cBhvr>
-                                    </p:anim>
-                                    <p:anim from="0" to="-1.0" calcmode="lin" valueType="num">
-                                      <p:cBhvr>
-                                        <p:cTn id="8" dur="200" decel="50000" autoRev="1" fill="hold">
-                                          <p:stCondLst>
-                                            <p:cond delay="600"/>
-                                          </p:stCondLst>
-                                        </p:cTn>
-                                        <p:tgtEl>
-                                          <p:spTgt spid="6"/>
-                                        </p:tgtEl>
-                                        <p:attrNameLst>
-                                          <p:attrName>xshear</p:attrName>
-                                        </p:attrNameLst>
-                                      </p:cBhvr>
-                                    </p:anim>
-                                    <p:animScale>
-                                      <p:cBhvr>
-                                        <p:cTn id="9" dur="200" decel="100000" autoRev="1" fill="hold">
-                                          <p:stCondLst>
-                                            <p:cond delay="600"/>
-                                          </p:stCondLst>
-                                        </p:cTn>
-                                        <p:tgtEl>
-                                          <p:spTgt spid="6"/>
-                                        </p:tgtEl>
-                                      </p:cBhvr>
-                                      <p:from x="100000" y="100000"/>
-                                      <p:to x="80000" y="100000"/>
-                                    </p:animScale>
-                                    <p:anim by="(#ppt_h/3+#ppt_w*0.1)" calcmode="lin" valueType="num">
-                                      <p:cBhvr additive="sum">
-                                        <p:cTn id="10" dur="200" decel="100000" autoRev="1" fill="hold">
-                                          <p:stCondLst>
-                                            <p:cond delay="600"/>
-                                          </p:stCondLst>
-                                        </p:cTn>
-                                        <p:tgtEl>
-                                          <p:spTgt spid="6"/>
-                                        </p:tgtEl>
-                                        <p:attrNameLst>
-                                          <p:attrName>ppt_x</p:attrName>
-                                        </p:attrNameLst>
-                                      </p:cBhvr>
-                                    </p:anim>
-                                  </p:childTnLst>
-                                </p:cTn>
-                              </p:par>
-                            </p:childTnLst>
-                          </p:cTn>
-                        </p:par>
-                      </p:childTnLst>
-                    </p:cTn>
-                  </p:par>
-                  <p:par>
-                    <p:cTn id="11" fill="hold">
-                      <p:stCondLst>
-                        <p:cond delay="indefinite"/>
-                      </p:stCondLst>
-                      <p:childTnLst>
-                        <p:par>
-                          <p:cTn id="12" fill="hold">
-                            <p:stCondLst>
-                              <p:cond delay="0"/>
-                            </p:stCondLst>
-                            <p:childTnLst>
-                              <p:par>
-                                <p:cTn id="13" presetID="34" presetClass="entr" presetSubtype="0" fill="hold" grpId="0" nodeType="clickEffect">
-                                  <p:stCondLst>
-                                    <p:cond delay="0"/>
-                                  </p:stCondLst>
-                                  <p:childTnLst>
-                                    <p:set>
-                                      <p:cBhvr>
-                                        <p:cTn id="14" dur="1" fill="hold">
-                                          <p:stCondLst>
-                                            <p:cond delay="0"/>
-                                          </p:stCondLst>
-                                        </p:cTn>
-                                        <p:tgtEl>
-                                          <p:spTgt spid="8"/>
-                                        </p:tgtEl>
-                                        <p:attrNameLst>
-                                          <p:attrName>style.visibility</p:attrName>
-                                        </p:attrNameLst>
-                                      </p:cBhvr>
-                                      <p:to>
-                                        <p:strVal val="visible"/>
-                                      </p:to>
-                                    </p:set>
-                                    <p:anim from="(-#ppt_w/2)" to="(#ppt_x)" calcmode="lin" valueType="num">
-                                      <p:cBhvr>
-                                        <p:cTn id="15" dur="600" fill="hold">
-                                          <p:stCondLst>
-                                            <p:cond delay="0"/>
-                                          </p:stCondLst>
-                                        </p:cTn>
-                                        <p:tgtEl>
-                                          <p:spTgt spid="8"/>
-                                        </p:tgtEl>
-                                        <p:attrNameLst>
-                                          <p:attrName>ppt_x</p:attrName>
-                                        </p:attrNameLst>
-                                      </p:cBhvr>
-                                    </p:anim>
-                                    <p:anim from="0" to="-1.0" calcmode="lin" valueType="num">
-                                      <p:cBhvr>
-                                        <p:cTn id="16" dur="200" decel="50000" autoRev="1" fill="hold">
-                                          <p:stCondLst>
-                                            <p:cond delay="600"/>
-                                          </p:stCondLst>
-                                        </p:cTn>
-                                        <p:tgtEl>
-                                          <p:spTgt spid="8"/>
-                                        </p:tgtEl>
-                                        <p:attrNameLst>
-                                          <p:attrName>xshear</p:attrName>
-                                        </p:attrNameLst>
-                                      </p:cBhvr>
-                                    </p:anim>
-                                    <p:animScale>
-                                      <p:cBhvr>
-                                        <p:cTn id="17" dur="200" decel="100000" autoRev="1" fill="hold">
-                                          <p:stCondLst>
-                                            <p:cond delay="600"/>
-                                          </p:stCondLst>
-                                        </p:cTn>
-                                        <p:tgtEl>
-                                          <p:spTgt spid="8"/>
-                                        </p:tgtEl>
-                                      </p:cBhvr>
-                                      <p:from x="100000" y="100000"/>
-                                      <p:to x="80000" y="100000"/>
-                                    </p:animScale>
-                                    <p:anim by="(#ppt_h/3+#ppt_w*0.1)" calcmode="lin" valueType="num">
-                                      <p:cBhvr additive="sum">
-                                        <p:cTn id="18" dur="200" decel="100000" autoRev="1" fill="hold">
-                                          <p:stCondLst>
-                                            <p:cond delay="600"/>
-                                          </p:stCondLst>
-                                        </p:cTn>
-                                        <p:tgtEl>
-                                          <p:spTgt spid="8"/>
-                                        </p:tgtEl>
-                                        <p:attrNameLst>
-                                          <p:attrName>ppt_x</p:attrName>
-                                        </p:attrNameLst>
-                                      </p:cBhvr>
-                                    </p:anim>
-                                  </p:childTnLst>
-                                </p:cTn>
-                              </p:par>
-                            </p:childTnLst>
-                          </p:cTn>
-                        </p:par>
-                      </p:childTnLst>
-                    </p:cTn>
-                  </p:par>
-                  <p:par>
-                    <p:cTn id="19" fill="hold">
-                      <p:stCondLst>
-                        <p:cond delay="indefinite"/>
-                      </p:stCondLst>
-                      <p:childTnLst>
-                        <p:par>
-                          <p:cTn id="20" fill="hold">
-                            <p:stCondLst>
-                              <p:cond delay="0"/>
-                            </p:stCondLst>
-                            <p:childTnLst>
-                              <p:par>
-                                <p:cTn id="21" presetID="34" presetClass="entr" presetSubtype="0" fill="hold" grpId="0" nodeType="clickEffect">
-                                  <p:stCondLst>
-                                    <p:cond delay="0"/>
-                                  </p:stCondLst>
-                                  <p:childTnLst>
-                                    <p:set>
-                                      <p:cBhvr>
-                                        <p:cTn id="22" dur="1" fill="hold">
-                                          <p:stCondLst>
-                                            <p:cond delay="0"/>
-                                          </p:stCondLst>
-                                        </p:cTn>
-                                        <p:tgtEl>
-                                          <p:spTgt spid="10"/>
-                                        </p:tgtEl>
-                                        <p:attrNameLst>
-                                          <p:attrName>style.visibility</p:attrName>
-                                        </p:attrNameLst>
-                                      </p:cBhvr>
-                                      <p:to>
-                                        <p:strVal val="visible"/>
-                                      </p:to>
-                                    </p:set>
-                                    <p:anim from="(-#ppt_w/2)" to="(#ppt_x)" calcmode="lin" valueType="num">
-                                      <p:cBhvr>
-                                        <p:cTn id="23" dur="600" fill="hold">
-                                          <p:stCondLst>
-                                            <p:cond delay="0"/>
-                                          </p:stCondLst>
-                                        </p:cTn>
-                                        <p:tgtEl>
-                                          <p:spTgt spid="10"/>
-                                        </p:tgtEl>
-                                        <p:attrNameLst>
-                                          <p:attrName>ppt_x</p:attrName>
-                                        </p:attrNameLst>
-                                      </p:cBhvr>
-                                    </p:anim>
-                                    <p:anim from="0" to="-1.0" calcmode="lin" valueType="num">
-                                      <p:cBhvr>
-                                        <p:cTn id="24" dur="200" decel="50000" autoRev="1" fill="hold">
-                                          <p:stCondLst>
-                                            <p:cond delay="600"/>
-                                          </p:stCondLst>
-                                        </p:cTn>
-                                        <p:tgtEl>
-                                          <p:spTgt spid="10"/>
-                                        </p:tgtEl>
-                                        <p:attrNameLst>
-                                          <p:attrName>xshear</p:attrName>
-                                        </p:attrNameLst>
-                                      </p:cBhvr>
-                                    </p:anim>
-                                    <p:animScale>
-                                      <p:cBhvr>
-                                        <p:cTn id="25" dur="200" decel="100000" autoRev="1" fill="hold">
-                                          <p:stCondLst>
-                                            <p:cond delay="600"/>
-                                          </p:stCondLst>
-                                        </p:cTn>
-                                        <p:tgtEl>
-                                          <p:spTgt spid="10"/>
-                                        </p:tgtEl>
-                                      </p:cBhvr>
-                                      <p:from x="100000" y="100000"/>
-                                      <p:to x="80000" y="100000"/>
-                                    </p:animScale>
-                                    <p:anim by="(#ppt_h/3+#ppt_w*0.1)" calcmode="lin" valueType="num">
-                                      <p:cBhvr additive="sum">
-                                        <p:cTn id="26" dur="200" decel="100000" autoRev="1" fill="hold">
-                                          <p:stCondLst>
-                                            <p:cond delay="600"/>
-                                          </p:stCondLst>
-                                        </p:cTn>
-                                        <p:tgtEl>
-                                          <p:spTgt spid="10"/>
-                                        </p:tgtEl>
-                                        <p:attrNameLst>
-                                          <p:attrName>ppt_x</p:attrName>
-                                        </p:attrNameLst>
-                                      </p:cBhvr>
-                                    </p:anim>
-                                  </p:childTnLst>
-                                </p:cTn>
-                              </p:par>
-                            </p:childTnLst>
-                          </p:cTn>
-                        </p:par>
-                      </p:childTnLst>
-                    </p:cTn>
-                  </p:par>
-                  <p:par>
-                    <p:cTn id="27" fill="hold">
-                      <p:stCondLst>
-                        <p:cond delay="indefinite"/>
-                      </p:stCondLst>
-                      <p:childTnLst>
-                        <p:par>
-                          <p:cTn id="28" fill="hold">
-                            <p:stCondLst>
-                              <p:cond delay="0"/>
-                            </p:stCondLst>
-                            <p:childTnLst>
-                              <p:par>
-                                <p:cTn id="29" presetID="34" presetClass="entr" presetSubtype="0" fill="hold" grpId="0" nodeType="clickEffect">
-                                  <p:stCondLst>
-                                    <p:cond delay="0"/>
-                                  </p:stCondLst>
-                                  <p:childTnLst>
-                                    <p:set>
-                                      <p:cBhvr>
-                                        <p:cTn id="30" dur="1" fill="hold">
-                                          <p:stCondLst>
-                                            <p:cond delay="0"/>
-                                          </p:stCondLst>
-                                        </p:cTn>
-                                        <p:tgtEl>
-                                          <p:spTgt spid="11"/>
-                                        </p:tgtEl>
-                                        <p:attrNameLst>
-                                          <p:attrName>style.visibility</p:attrName>
-                                        </p:attrNameLst>
-                                      </p:cBhvr>
-                                      <p:to>
-                                        <p:strVal val="visible"/>
-                                      </p:to>
-                                    </p:set>
-                                    <p:anim from="(-#ppt_w/2)" to="(#ppt_x)" calcmode="lin" valueType="num">
-                                      <p:cBhvr>
-                                        <p:cTn id="31" dur="600" fill="hold">
-                                          <p:stCondLst>
-                                            <p:cond delay="0"/>
-                                          </p:stCondLst>
-                                        </p:cTn>
-                                        <p:tgtEl>
-                                          <p:spTgt spid="11"/>
-                                        </p:tgtEl>
-                                        <p:attrNameLst>
-                                          <p:attrName>ppt_x</p:attrName>
-                                        </p:attrNameLst>
-                                      </p:cBhvr>
-                                    </p:anim>
-                                    <p:anim from="0" to="-1.0" calcmode="lin" valueType="num">
-                                      <p:cBhvr>
-                                        <p:cTn id="32" dur="200" decel="50000" autoRev="1" fill="hold">
-                                          <p:stCondLst>
-                                            <p:cond delay="600"/>
-                                          </p:stCondLst>
-                                        </p:cTn>
-                                        <p:tgtEl>
-                                          <p:spTgt spid="11"/>
-                                        </p:tgtEl>
-                                        <p:attrNameLst>
-                                          <p:attrName>xshear</p:attrName>
-                                        </p:attrNameLst>
-                                      </p:cBhvr>
-                                    </p:anim>
-                                    <p:animScale>
-                                      <p:cBhvr>
-                                        <p:cTn id="33" dur="200" decel="100000" autoRev="1" fill="hold">
-                                          <p:stCondLst>
-                                            <p:cond delay="600"/>
-                                          </p:stCondLst>
-                                        </p:cTn>
-                                        <p:tgtEl>
-                                          <p:spTgt spid="11"/>
-                                        </p:tgtEl>
-                                      </p:cBhvr>
-                                      <p:from x="100000" y="100000"/>
-                                      <p:to x="80000" y="100000"/>
-                                    </p:animScale>
-                                    <p:anim by="(#ppt_h/3+#ppt_w*0.1)" calcmode="lin" valueType="num">
-                                      <p:cBhvr additive="sum">
-                                        <p:cTn id="34" dur="200" decel="100000" autoRev="1" fill="hold">
-                                          <p:stCondLst>
-                                            <p:cond delay="600"/>
-                                          </p:stCondLst>
-                                        </p:cTn>
-                                        <p:tgtEl>
-                                          <p:spTgt spid="11"/>
-                                        </p:tgtEl>
-                                        <p:attrNameLst>
-                                          <p:attrName>ppt_x</p:attrName>
-                                        </p:attrNameLst>
-                                      </p:cBhvr>
-                                    </p:anim>
-                                  </p:childTnLst>
-                                </p:cTn>
-                              </p:par>
-                            </p:childTnLst>
-                          </p:cTn>
-                        </p:par>
-                      </p:childTnLst>
-                    </p:cTn>
-                  </p:par>
-                </p:childTnLst>
-              </p:cTn>
-              <p:prevCondLst>
-                <p:cond evt="onPrev" delay="0">
-                  <p:tgtEl>
-                    <p:sldTgt/>
-                  </p:tgtEl>
-                </p:cond>
-              </p:prevCondLst>
-              <p:nextCondLst>
-                <p:cond evt="onNext" delay="0">
-                  <p:tgtEl>
-                    <p:sldTgt/>
-                  </p:tgtEl>
-                </p:cond>
-              </p:nextCondLst>
-            </p:seq>
-          </p:childTnLst>
-        </p:cTn>
-      </p:par>
-    </p:tnLst>
-    <p:bldLst>
-      <p:bldP spid="6" grpId="0"/>
-      <p:bldP spid="8" grpId="0"/>
-      <p:bldP spid="10" grpId="0"/>
-      <p:bldP spid="11" grpId="0"/>
     </p:bldLst>
   </p:timing>
 </p:sld>

</xml_diff>